<commit_message>
Add spectrogram evidence to presentation
</commit_message>
<xml_diff>
--- a/presentation/stemgen_highlight_3min.pptx
+++ b/presentation/stemgen_highlight_3min.pptx
@@ -3099,8 +3099,8 @@
         </p:nvSpPr>
         <p:spPr>
           <a:xfrm>
-            <a:off x="502920" y="320040"/>
-            <a:ext cx="11155680" cy="685800"/>
+            <a:off x="502920" y="292608"/>
+            <a:ext cx="11155680" cy="566928"/>
           </a:xfrm>
           <a:prstGeom prst="rect">
             <a:avLst/>
@@ -3114,7 +3114,7 @@
           <a:lstStyle/>
           <a:p>
             <a:pPr>
-              <a:defRPr sz="3000" b="1">
+              <a:defRPr sz="2800" b="1">
                 <a:solidFill>
                   <a:srgbClr val="142D50"/>
                 </a:solidFill>
@@ -3134,8 +3134,8 @@
         </p:nvSpPr>
         <p:spPr>
           <a:xfrm>
-            <a:off x="530352" y="960120"/>
-            <a:ext cx="10515600" cy="320040"/>
+            <a:off x="530352" y="841248"/>
+            <a:ext cx="10789920" cy="292608"/>
           </a:xfrm>
           <a:prstGeom prst="rect">
             <a:avLst/>
@@ -3149,7 +3149,7 @@
           <a:lstStyle/>
           <a:p>
             <a:pPr>
-              <a:defRPr sz="1400">
+              <a:defRPr sz="1300">
                 <a:solidFill>
                   <a:srgbClr val="55606E"/>
                 </a:solidFill>
@@ -3214,8 +3214,8 @@
         </p:nvSpPr>
         <p:spPr>
           <a:xfrm>
-            <a:off x="914400" y="1581912"/>
-            <a:ext cx="4892040" cy="320040"/>
+            <a:off x="886968" y="1554480"/>
+            <a:ext cx="4946903" cy="292608"/>
           </a:xfrm>
           <a:prstGeom prst="rect">
             <a:avLst/>
@@ -3229,7 +3229,7 @@
           <a:lstStyle/>
           <a:p>
             <a:pPr>
-              <a:defRPr sz="1400" b="1">
+              <a:defRPr sz="1350" b="1">
                 <a:solidFill>
                   <a:srgbClr val="2969B0"/>
                 </a:solidFill>
@@ -3249,8 +3249,8 @@
         </p:nvSpPr>
         <p:spPr>
           <a:xfrm>
-            <a:off x="914400" y="2011680"/>
-            <a:ext cx="4892040" cy="3584448"/>
+            <a:off x="886968" y="1938528"/>
+            <a:ext cx="4946903" cy="3703320"/>
           </a:xfrm>
           <a:prstGeom prst="rect">
             <a:avLst/>
@@ -3258,7 +3258,7 @@
           <a:noFill/>
         </p:spPr>
         <p:txBody>
-          <a:bodyPr wrap="none">
+          <a:bodyPr wrap="square">
             <a:spAutoFit/>
           </a:bodyPr>
           <a:lstStyle/>
@@ -3267,7 +3267,7 @@
               <a:spcAft>
                 <a:spcPts val="400"/>
               </a:spcAft>
-              <a:defRPr sz="1500">
+              <a:defRPr sz="1400">
                 <a:solidFill>
                   <a:srgbClr val="1C222D"/>
                 </a:solidFill>
@@ -3282,7 +3282,7 @@
               <a:spcAft>
                 <a:spcPts val="400"/>
               </a:spcAft>
-              <a:defRPr sz="1500">
+              <a:defRPr sz="1400">
                 <a:solidFill>
                   <a:srgbClr val="1C222D"/>
                 </a:solidFill>
@@ -3297,7 +3297,7 @@
               <a:spcAft>
                 <a:spcPts val="400"/>
               </a:spcAft>
-              <a:defRPr sz="1500">
+              <a:defRPr sz="1400">
                 <a:solidFill>
                   <a:srgbClr val="1C222D"/>
                 </a:solidFill>
@@ -3362,8 +3362,8 @@
         </p:nvSpPr>
         <p:spPr>
           <a:xfrm>
-            <a:off x="6537960" y="1581912"/>
-            <a:ext cx="4617720" cy="320040"/>
+            <a:off x="6510528" y="1554480"/>
+            <a:ext cx="4672583" cy="292608"/>
           </a:xfrm>
           <a:prstGeom prst="rect">
             <a:avLst/>
@@ -3377,7 +3377,7 @@
           <a:lstStyle/>
           <a:p>
             <a:pPr>
-              <a:defRPr sz="1400" b="1">
+              <a:defRPr sz="1350" b="1">
                 <a:solidFill>
                   <a:srgbClr val="2969B0"/>
                 </a:solidFill>
@@ -3397,8 +3397,8 @@
         </p:nvSpPr>
         <p:spPr>
           <a:xfrm>
-            <a:off x="6537960" y="2011680"/>
-            <a:ext cx="4617720" cy="3584448"/>
+            <a:off x="6510528" y="1938528"/>
+            <a:ext cx="4672583" cy="3703320"/>
           </a:xfrm>
           <a:prstGeom prst="rect">
             <a:avLst/>
@@ -3406,7 +3406,7 @@
           <a:noFill/>
         </p:spPr>
         <p:txBody>
-          <a:bodyPr wrap="none">
+          <a:bodyPr wrap="square">
             <a:spAutoFit/>
           </a:bodyPr>
           <a:lstStyle/>
@@ -3415,7 +3415,7 @@
               <a:spcAft>
                 <a:spcPts val="400"/>
               </a:spcAft>
-              <a:defRPr sz="1500">
+              <a:defRPr sz="1400">
                 <a:solidFill>
                   <a:srgbClr val="1C222D"/>
                 </a:solidFill>
@@ -3430,7 +3430,7 @@
               <a:spcAft>
                 <a:spcPts val="400"/>
               </a:spcAft>
-              <a:defRPr sz="1500">
+              <a:defRPr sz="1400">
                 <a:solidFill>
                   <a:srgbClr val="1C222D"/>
                 </a:solidFill>
@@ -3445,7 +3445,7 @@
               <a:spcAft>
                 <a:spcPts val="400"/>
               </a:spcAft>
-              <a:defRPr sz="1500">
+              <a:defRPr sz="1400">
                 <a:solidFill>
                   <a:srgbClr val="1C222D"/>
                 </a:solidFill>
@@ -3633,8 +3633,8 @@
         </p:nvSpPr>
         <p:spPr>
           <a:xfrm>
-            <a:off x="502920" y="320040"/>
-            <a:ext cx="11155680" cy="685800"/>
+            <a:off x="502920" y="292608"/>
+            <a:ext cx="11155680" cy="566928"/>
           </a:xfrm>
           <a:prstGeom prst="rect">
             <a:avLst/>
@@ -3648,7 +3648,7 @@
           <a:lstStyle/>
           <a:p>
             <a:pPr>
-              <a:defRPr sz="3000" b="1">
+              <a:defRPr sz="2800" b="1">
                 <a:solidFill>
                   <a:srgbClr val="142D50"/>
                 </a:solidFill>
@@ -4216,8 +4216,8 @@
         </p:nvSpPr>
         <p:spPr>
           <a:xfrm>
-            <a:off x="1005840" y="3410712"/>
-            <a:ext cx="4846320" cy="320040"/>
+            <a:off x="978408" y="3383279"/>
+            <a:ext cx="4901183" cy="292608"/>
           </a:xfrm>
           <a:prstGeom prst="rect">
             <a:avLst/>
@@ -4231,7 +4231,7 @@
           <a:lstStyle/>
           <a:p>
             <a:pPr>
-              <a:defRPr sz="1400" b="1">
+              <a:defRPr sz="1350" b="1">
                 <a:solidFill>
                   <a:srgbClr val="2969B0"/>
                 </a:solidFill>
@@ -4251,8 +4251,8 @@
         </p:nvSpPr>
         <p:spPr>
           <a:xfrm>
-            <a:off x="1005840" y="3840480"/>
-            <a:ext cx="4846320" cy="1618487"/>
+            <a:off x="978408" y="3767328"/>
+            <a:ext cx="4901183" cy="1737360"/>
           </a:xfrm>
           <a:prstGeom prst="rect">
             <a:avLst/>
@@ -4260,7 +4260,7 @@
           <a:noFill/>
         </p:spPr>
         <p:txBody>
-          <a:bodyPr wrap="none">
+          <a:bodyPr wrap="square">
             <a:spAutoFit/>
           </a:bodyPr>
           <a:lstStyle/>
@@ -4269,7 +4269,7 @@
               <a:spcAft>
                 <a:spcPts val="400"/>
               </a:spcAft>
-              <a:defRPr sz="1500">
+              <a:defRPr sz="1400">
                 <a:solidFill>
                   <a:srgbClr val="1C222D"/>
                 </a:solidFill>
@@ -4284,7 +4284,7 @@
               <a:spcAft>
                 <a:spcPts val="400"/>
               </a:spcAft>
-              <a:defRPr sz="1500">
+              <a:defRPr sz="1400">
                 <a:solidFill>
                   <a:srgbClr val="1C222D"/>
                 </a:solidFill>
@@ -4299,7 +4299,7 @@
               <a:spcAft>
                 <a:spcPts val="400"/>
               </a:spcAft>
-              <a:defRPr sz="1500">
+              <a:defRPr sz="1400">
                 <a:solidFill>
                   <a:srgbClr val="1C222D"/>
                 </a:solidFill>
@@ -4314,7 +4314,7 @@
               <a:spcAft>
                 <a:spcPts val="400"/>
               </a:spcAft>
-              <a:defRPr sz="1500">
+              <a:defRPr sz="1400">
                 <a:solidFill>
                   <a:srgbClr val="1C222D"/>
                 </a:solidFill>
@@ -4379,8 +4379,8 @@
         </p:nvSpPr>
         <p:spPr>
           <a:xfrm>
-            <a:off x="6583680" y="3410712"/>
-            <a:ext cx="4663440" cy="320040"/>
+            <a:off x="6556248" y="3383279"/>
+            <a:ext cx="4718303" cy="292608"/>
           </a:xfrm>
           <a:prstGeom prst="rect">
             <a:avLst/>
@@ -4394,7 +4394,7 @@
           <a:lstStyle/>
           <a:p>
             <a:pPr>
-              <a:defRPr sz="1400" b="1">
+              <a:defRPr sz="1350" b="1">
                 <a:solidFill>
                   <a:srgbClr val="2969B0"/>
                 </a:solidFill>
@@ -4414,8 +4414,8 @@
         </p:nvSpPr>
         <p:spPr>
           <a:xfrm>
-            <a:off x="6583680" y="3840480"/>
-            <a:ext cx="4663440" cy="1618487"/>
+            <a:off x="6556248" y="3767328"/>
+            <a:ext cx="4718303" cy="1737360"/>
           </a:xfrm>
           <a:prstGeom prst="rect">
             <a:avLst/>
@@ -4423,7 +4423,7 @@
           <a:noFill/>
         </p:spPr>
         <p:txBody>
-          <a:bodyPr wrap="none">
+          <a:bodyPr wrap="square">
             <a:spAutoFit/>
           </a:bodyPr>
           <a:lstStyle/>
@@ -4432,7 +4432,7 @@
               <a:spcAft>
                 <a:spcPts val="400"/>
               </a:spcAft>
-              <a:defRPr sz="1500">
+              <a:defRPr sz="1400">
                 <a:solidFill>
                   <a:srgbClr val="1C222D"/>
                 </a:solidFill>
@@ -4447,7 +4447,7 @@
               <a:spcAft>
                 <a:spcPts val="400"/>
               </a:spcAft>
-              <a:defRPr sz="1500">
+              <a:defRPr sz="1400">
                 <a:solidFill>
                   <a:srgbClr val="1C222D"/>
                 </a:solidFill>
@@ -4462,7 +4462,7 @@
               <a:spcAft>
                 <a:spcPts val="400"/>
               </a:spcAft>
-              <a:defRPr sz="1500">
+              <a:defRPr sz="1400">
                 <a:solidFill>
                   <a:srgbClr val="1C222D"/>
                 </a:solidFill>
@@ -4615,8 +4615,8 @@
         </p:nvSpPr>
         <p:spPr>
           <a:xfrm>
-            <a:off x="502920" y="320040"/>
-            <a:ext cx="11155680" cy="685800"/>
+            <a:off x="502920" y="292608"/>
+            <a:ext cx="11155680" cy="566928"/>
           </a:xfrm>
           <a:prstGeom prst="rect">
             <a:avLst/>
@@ -4630,14 +4630,14 @@
           <a:lstStyle/>
           <a:p>
             <a:pPr>
-              <a:defRPr sz="3000" b="1">
+              <a:defRPr sz="2800" b="1">
                 <a:solidFill>
                   <a:srgbClr val="142D50"/>
                 </a:solidFill>
               </a:defRPr>
             </a:pPr>
             <a:r>
-              <a:t>Latest Results</a:t>
+              <a:t>Results and Effectiveness</a:t>
             </a:r>
           </a:p>
         </p:txBody>
@@ -4650,8 +4650,8 @@
         </p:nvSpPr>
         <p:spPr>
           <a:xfrm>
-            <a:off x="530352" y="960120"/>
-            <a:ext cx="10515600" cy="320040"/>
+            <a:off x="530352" y="841248"/>
+            <a:ext cx="10789920" cy="292608"/>
           </a:xfrm>
           <a:prstGeom prst="rect">
             <a:avLst/>
@@ -4665,408 +4665,28 @@
           <a:lstStyle/>
           <a:p>
             <a:pPr>
-              <a:defRPr sz="1400">
+              <a:defRPr sz="1300">
                 <a:solidFill>
                   <a:srgbClr val="55606E"/>
                 </a:solidFill>
               </a:defRPr>
             </a:pPr>
             <a:r>
-              <a:t>1000-track stride10 run is the current strongest baseline</a:t>
-            </a:r>
-          </a:p>
-        </p:txBody>
-      </p:sp>
-      <p:graphicFrame>
-        <p:nvGraphicFramePr>
-          <p:cNvPr id="4" name="Table 3"/>
-          <p:cNvGraphicFramePr>
-            <a:graphicFrameLocks noGrp="1"/>
-          </p:cNvGraphicFramePr>
-          <p:nvPr/>
-        </p:nvGraphicFramePr>
-        <p:xfrm>
-          <a:off x="548640" y="1417320"/>
-          <a:ext cx="9555480" cy="1417320"/>
-        </p:xfrm>
-        <a:graphic>
-          <a:graphicData uri="http://schemas.openxmlformats.org/drawingml/2006/table">
-            <a:tbl>
-              <a:tblPr firstRow="1" bandRow="1">
-                <a:tableStyleId>{5C22544A-7EE6-4342-B048-85BDC9FD1C3A}</a:tableStyleId>
-              </a:tblPr>
-              <a:tblGrid>
-                <a:gridCol w="2240280"/>
-                <a:gridCol w="1325880"/>
-                <a:gridCol w="2514600"/>
-                <a:gridCol w="1828800"/>
-                <a:gridCol w="1645920"/>
-              </a:tblGrid>
-              <a:tr h="472440">
-                <a:tc>
-                  <a:txBody>
-                    <a:bodyPr/>
-                    <a:lstStyle/>
-                    <a:p>
-                      <a:pPr>
-                        <a:defRPr b="1" sz="1200">
-                          <a:solidFill>
-                            <a:srgbClr val="FFFFFF"/>
-                          </a:solidFill>
-                        </a:defRPr>
-                      </a:pPr>
-                      <a:r>
-                        <a:t>Run</a:t>
-                      </a:r>
-                    </a:p>
-                  </a:txBody>
-                  <a:tcPr>
-                    <a:solidFill>
-                      <a:srgbClr val="142D50"/>
-                    </a:solidFill>
-                  </a:tcPr>
-                </a:tc>
-                <a:tc>
-                  <a:txBody>
-                    <a:bodyPr/>
-                    <a:lstStyle/>
-                    <a:p>
-                      <a:pPr>
-                        <a:defRPr b="1" sz="1200">
-                          <a:solidFill>
-                            <a:srgbClr val="FFFFFF"/>
-                          </a:solidFill>
-                        </a:defRPr>
-                      </a:pPr>
-                      <a:r>
-                        <a:t>Clips</a:t>
-                      </a:r>
-                    </a:p>
-                  </a:txBody>
-                  <a:tcPr>
-                    <a:solidFill>
-                      <a:srgbClr val="142D50"/>
-                    </a:solidFill>
-                  </a:tcPr>
-                </a:tc>
-                <a:tc>
-                  <a:txBody>
-                    <a:bodyPr/>
-                    <a:lstStyle/>
-                    <a:p>
-                      <a:pPr>
-                        <a:defRPr b="1" sz="1200">
-                          <a:solidFill>
-                            <a:srgbClr val="FFFFFF"/>
-                          </a:solidFill>
-                        </a:defRPr>
-                      </a:pPr>
-                      <a:r>
-                        <a:t>Sampling</a:t>
-                      </a:r>
-                    </a:p>
-                  </a:txBody>
-                  <a:tcPr>
-                    <a:solidFill>
-                      <a:srgbClr val="142D50"/>
-                    </a:solidFill>
-                  </a:tcPr>
-                </a:tc>
-                <a:tc>
-                  <a:txBody>
-                    <a:bodyPr/>
-                    <a:lstStyle/>
-                    <a:p>
-                      <a:pPr>
-                        <a:defRPr b="1" sz="1200">
-                          <a:solidFill>
-                            <a:srgbClr val="FFFFFF"/>
-                          </a:solidFill>
-                        </a:defRPr>
-                      </a:pPr>
-                      <a:r>
-                        <a:t>Best Val Loss</a:t>
-                      </a:r>
-                    </a:p>
-                  </a:txBody>
-                  <a:tcPr>
-                    <a:solidFill>
-                      <a:srgbClr val="142D50"/>
-                    </a:solidFill>
-                  </a:tcPr>
-                </a:tc>
-                <a:tc>
-                  <a:txBody>
-                    <a:bodyPr/>
-                    <a:lstStyle/>
-                    <a:p>
-                      <a:pPr>
-                        <a:defRPr b="1" sz="1200">
-                          <a:solidFill>
-                            <a:srgbClr val="FFFFFF"/>
-                          </a:solidFill>
-                        </a:defRPr>
-                      </a:pPr>
-                      <a:r>
-                        <a:t>Best Val Acc</a:t>
-                      </a:r>
-                    </a:p>
-                  </a:txBody>
-                  <a:tcPr>
-                    <a:solidFill>
-                      <a:srgbClr val="142D50"/>
-                    </a:solidFill>
-                  </a:tcPr>
-                </a:tc>
-              </a:tr>
-              <a:tr h="472440">
-                <a:tc>
-                  <a:txBody>
-                    <a:bodyPr/>
-                    <a:lstStyle/>
-                    <a:p>
-                      <a:pPr>
-                        <a:defRPr sz="1200">
-                          <a:solidFill>
-                            <a:srgbClr val="1C222D"/>
-                          </a:solidFill>
-                        </a:defRPr>
-                      </a:pPr>
-                      <a:r>
-                        <a:t>550 cached</a:t>
-                      </a:r>
-                    </a:p>
-                  </a:txBody>
-                  <a:tcPr>
-                    <a:solidFill>
-                      <a:srgbClr val="FFFFFF"/>
-                    </a:solidFill>
-                  </a:tcPr>
-                </a:tc>
-                <a:tc>
-                  <a:txBody>
-                    <a:bodyPr/>
-                    <a:lstStyle/>
-                    <a:p>
-                      <a:pPr>
-                        <a:defRPr sz="1200">
-                          <a:solidFill>
-                            <a:srgbClr val="1C222D"/>
-                          </a:solidFill>
-                        </a:defRPr>
-                      </a:pPr>
-                      <a:r>
-                        <a:t>26,400</a:t>
-                      </a:r>
-                    </a:p>
-                  </a:txBody>
-                  <a:tcPr>
-                    <a:solidFill>
-                      <a:srgbClr val="FFFFFF"/>
-                    </a:solidFill>
-                  </a:tcPr>
-                </a:tc>
-                <a:tc>
-                  <a:txBody>
-                    <a:bodyPr/>
-                    <a:lstStyle/>
-                    <a:p>
-                      <a:pPr>
-                        <a:defRPr sz="1200">
-                          <a:solidFill>
-                            <a:srgbClr val="1C222D"/>
-                          </a:solidFill>
-                        </a:defRPr>
-                      </a:pPr>
-                      <a:r>
-                        <a:t>sampled cache</a:t>
-                      </a:r>
-                    </a:p>
-                  </a:txBody>
-                  <a:tcPr>
-                    <a:solidFill>
-                      <a:srgbClr val="FFFFFF"/>
-                    </a:solidFill>
-                  </a:tcPr>
-                </a:tc>
-                <a:tc>
-                  <a:txBody>
-                    <a:bodyPr/>
-                    <a:lstStyle/>
-                    <a:p>
-                      <a:pPr>
-                        <a:defRPr sz="1200">
-                          <a:solidFill>
-                            <a:srgbClr val="1C222D"/>
-                          </a:solidFill>
-                        </a:defRPr>
-                      </a:pPr>
-                      <a:r>
-                        <a:t>3.4507</a:t>
-                      </a:r>
-                    </a:p>
-                  </a:txBody>
-                  <a:tcPr>
-                    <a:solidFill>
-                      <a:srgbClr val="FFFFFF"/>
-                    </a:solidFill>
-                  </a:tcPr>
-                </a:tc>
-                <a:tc>
-                  <a:txBody>
-                    <a:bodyPr/>
-                    <a:lstStyle/>
-                    <a:p>
-                      <a:pPr>
-                        <a:defRPr sz="1200">
-                          <a:solidFill>
-                            <a:srgbClr val="1C222D"/>
-                          </a:solidFill>
-                        </a:defRPr>
-                      </a:pPr>
-                      <a:r>
-                        <a:t>0.521</a:t>
-                      </a:r>
-                    </a:p>
-                  </a:txBody>
-                  <a:tcPr>
-                    <a:solidFill>
-                      <a:srgbClr val="FFFFFF"/>
-                    </a:solidFill>
-                  </a:tcPr>
-                </a:tc>
-              </a:tr>
-              <a:tr h="472440">
-                <a:tc>
-                  <a:txBody>
-                    <a:bodyPr/>
-                    <a:lstStyle/>
-                    <a:p>
-                      <a:pPr>
-                        <a:defRPr sz="1200">
-                          <a:solidFill>
-                            <a:srgbClr val="1C222D"/>
-                          </a:solidFill>
-                        </a:defRPr>
-                      </a:pPr>
-                      <a:r>
-                        <a:t>1000 stride10</a:t>
-                      </a:r>
-                    </a:p>
-                  </a:txBody>
-                  <a:tcPr>
-                    <a:solidFill>
-                      <a:srgbClr val="EFF5FC"/>
-                    </a:solidFill>
-                  </a:tcPr>
-                </a:tc>
-                <a:tc>
-                  <a:txBody>
-                    <a:bodyPr/>
-                    <a:lstStyle/>
-                    <a:p>
-                      <a:pPr>
-                        <a:defRPr sz="1200">
-                          <a:solidFill>
-                            <a:srgbClr val="1C222D"/>
-                          </a:solidFill>
-                        </a:defRPr>
-                      </a:pPr>
-                      <a:r>
-                        <a:t>22,928</a:t>
-                      </a:r>
-                    </a:p>
-                  </a:txBody>
-                  <a:tcPr>
-                    <a:solidFill>
-                      <a:srgbClr val="EFF5FC"/>
-                    </a:solidFill>
-                  </a:tcPr>
-                </a:tc>
-                <a:tc>
-                  <a:txBody>
-                    <a:bodyPr/>
-                    <a:lstStyle/>
-                    <a:p>
-                      <a:pPr>
-                        <a:defRPr sz="1200">
-                          <a:solidFill>
-                            <a:srgbClr val="1C222D"/>
-                          </a:solidFill>
-                        </a:defRPr>
-                      </a:pPr>
-                      <a:r>
-                        <a:t>non-overlap</a:t>
-                      </a:r>
-                    </a:p>
-                  </a:txBody>
-                  <a:tcPr>
-                    <a:solidFill>
-                      <a:srgbClr val="EFF5FC"/>
-                    </a:solidFill>
-                  </a:tcPr>
-                </a:tc>
-                <a:tc>
-                  <a:txBody>
-                    <a:bodyPr/>
-                    <a:lstStyle/>
-                    <a:p>
-                      <a:pPr>
-                        <a:defRPr sz="1200">
-                          <a:solidFill>
-                            <a:srgbClr val="1C222D"/>
-                          </a:solidFill>
-                        </a:defRPr>
-                      </a:pPr>
-                      <a:r>
-                        <a:t>3.0279</a:t>
-                      </a:r>
-                    </a:p>
-                  </a:txBody>
-                  <a:tcPr>
-                    <a:solidFill>
-                      <a:srgbClr val="EFF5FC"/>
-                    </a:solidFill>
-                  </a:tcPr>
-                </a:tc>
-                <a:tc>
-                  <a:txBody>
-                    <a:bodyPr/>
-                    <a:lstStyle/>
-                    <a:p>
-                      <a:pPr>
-                        <a:defRPr sz="1200">
-                          <a:solidFill>
-                            <a:srgbClr val="1C222D"/>
-                          </a:solidFill>
-                        </a:defRPr>
-                      </a:pPr>
-                      <a:r>
-                        <a:t>0.572</a:t>
-                      </a:r>
-                    </a:p>
-                  </a:txBody>
-                  <a:tcPr>
-                    <a:solidFill>
-                      <a:srgbClr val="EFF5FC"/>
-                    </a:solidFill>
-                  </a:tcPr>
-                </a:tc>
-              </a:tr>
-            </a:tbl>
-          </a:graphicData>
-        </a:graphic>
-      </p:graphicFrame>
-      <p:sp>
-        <p:nvSpPr>
-          <p:cNvPr id="5" name="Rounded Rectangle 4"/>
+              <a:t>Quantitative improvement plus spectrogram evidence</a:t>
+            </a:r>
+          </a:p>
+        </p:txBody>
+      </p:sp>
+      <p:sp>
+        <p:nvSpPr>
+          <p:cNvPr id="4" name="Rounded Rectangle 3"/>
           <p:cNvSpPr/>
           <p:nvPr/>
         </p:nvSpPr>
         <p:spPr>
           <a:xfrm>
-            <a:off x="822960" y="3246120"/>
-            <a:ext cx="5349240" cy="2331720"/>
+            <a:off x="502920" y="1234440"/>
+            <a:ext cx="3840480" cy="1325880"/>
           </a:xfrm>
           <a:prstGeom prst="roundRect">
             <a:avLst/>
@@ -5104,14 +4724,49 @@
       </p:sp>
       <p:sp>
         <p:nvSpPr>
+          <p:cNvPr id="5" name="TextBox 4"/>
+          <p:cNvSpPr txBox="1"/>
+          <p:nvPr/>
+        </p:nvSpPr>
+        <p:spPr>
+          <a:xfrm>
+            <a:off x="704088" y="1371600"/>
+            <a:ext cx="3438144" cy="292608"/>
+          </a:xfrm>
+          <a:prstGeom prst="rect">
+            <a:avLst/>
+          </a:prstGeom>
+          <a:noFill/>
+        </p:spPr>
+        <p:txBody>
+          <a:bodyPr wrap="none">
+            <a:spAutoFit/>
+          </a:bodyPr>
+          <a:lstStyle/>
+          <a:p>
+            <a:pPr>
+              <a:defRPr sz="1350" b="1">
+                <a:solidFill>
+                  <a:srgbClr val="2969B0"/>
+                </a:solidFill>
+              </a:defRPr>
+            </a:pPr>
+            <a:r>
+              <a:t>Best validation results</a:t>
+            </a:r>
+          </a:p>
+        </p:txBody>
+      </p:sp>
+      <p:sp>
+        <p:nvSpPr>
           <p:cNvPr id="6" name="TextBox 5"/>
           <p:cNvSpPr txBox="1"/>
           <p:nvPr/>
         </p:nvSpPr>
         <p:spPr>
           <a:xfrm>
-            <a:off x="1051560" y="3410712"/>
-            <a:ext cx="4892040" cy="320040"/>
+            <a:off x="704088" y="1755648"/>
+            <a:ext cx="3438144" cy="731519"/>
           </a:xfrm>
           <a:prstGeom prst="rect">
             <a:avLst/>
@@ -5119,42 +4774,7 @@
           <a:noFill/>
         </p:spPr>
         <p:txBody>
-          <a:bodyPr wrap="none">
-            <a:spAutoFit/>
-          </a:bodyPr>
-          <a:lstStyle/>
-          <a:p>
-            <a:pPr>
-              <a:defRPr sz="1400" b="1">
-                <a:solidFill>
-                  <a:srgbClr val="2969B0"/>
-                </a:solidFill>
-              </a:defRPr>
-            </a:pPr>
-            <a:r>
-              <a:t>1000-track run</a:t>
-            </a:r>
-          </a:p>
-        </p:txBody>
-      </p:sp>
-      <p:sp>
-        <p:nvSpPr>
-          <p:cNvPr id="7" name="TextBox 6"/>
-          <p:cNvSpPr txBox="1"/>
-          <p:nvPr/>
-        </p:nvSpPr>
-        <p:spPr>
-          <a:xfrm>
-            <a:off x="1051560" y="3840480"/>
-            <a:ext cx="4892040" cy="1618487"/>
-          </a:xfrm>
-          <a:prstGeom prst="rect">
-            <a:avLst/>
-          </a:prstGeom>
-          <a:noFill/>
-        </p:spPr>
-        <p:txBody>
-          <a:bodyPr wrap="none">
+          <a:bodyPr wrap="square">
             <a:spAutoFit/>
           </a:bodyPr>
           <a:lstStyle/>
@@ -5163,14 +4783,14 @@
               <a:spcAft>
                 <a:spcPts val="400"/>
               </a:spcAft>
-              <a:defRPr sz="1500">
+              <a:defRPr sz="1250">
                 <a:solidFill>
                   <a:srgbClr val="1C222D"/>
                 </a:solidFill>
               </a:defRPr>
             </a:pPr>
             <a:r>
-              <a:t>Fixed 10-second stride windows</a:t>
+              <a:t>550 cached: loss 3.4507, acc 0.521</a:t>
             </a:r>
           </a:p>
           <a:p>
@@ -5178,14 +4798,14 @@
               <a:spcAft>
                 <a:spcPts val="400"/>
               </a:spcAft>
-              <a:defRPr sz="1500">
+              <a:defRPr sz="1250">
                 <a:solidFill>
                   <a:srgbClr val="1C222D"/>
                 </a:solidFill>
               </a:defRPr>
             </a:pPr>
             <a:r>
-              <a:t>Filtered 2,587 inactive clips</a:t>
+              <a:t>1000 stride10: loss 3.0279, acc 0.572</a:t>
             </a:r>
           </a:p>
           <a:p>
@@ -5193,53 +4813,38 @@
               <a:spcAft>
                 <a:spcPts val="400"/>
               </a:spcAft>
-              <a:defRPr sz="1500">
+              <a:defRPr sz="1250">
                 <a:solidFill>
                   <a:srgbClr val="1C222D"/>
                 </a:solidFill>
               </a:defRPr>
             </a:pPr>
             <a:r>
-              <a:t>Warm-started from 550 best checkpoint</a:t>
-            </a:r>
-          </a:p>
-          <a:p>
-            <a:pPr>
-              <a:spcAft>
-                <a:spcPts val="400"/>
-              </a:spcAft>
-              <a:defRPr sz="1500">
-                <a:solidFill>
-                  <a:srgbClr val="1C222D"/>
-                </a:solidFill>
-              </a:defRPr>
-            </a:pPr>
-            <a:r>
-              <a:t>Best checkpoint: epoch 19</a:t>
-            </a:r>
-          </a:p>
-        </p:txBody>
-      </p:sp>
-      <p:sp>
-        <p:nvSpPr>
-          <p:cNvPr id="8" name="Rounded Rectangle 7"/>
+              <a:t>Validation loss improved by ~12.3%</a:t>
+            </a:r>
+          </a:p>
+        </p:txBody>
+      </p:sp>
+      <p:sp>
+        <p:nvSpPr>
+          <p:cNvPr id="7" name="Rounded Rectangle 6"/>
           <p:cNvSpPr/>
           <p:nvPr/>
         </p:nvSpPr>
         <p:spPr>
           <a:xfrm>
-            <a:off x="6583680" y="3246120"/>
-            <a:ext cx="4480560" cy="2331720"/>
+            <a:off x="502920" y="2743200"/>
+            <a:ext cx="3840480" cy="1417320"/>
           </a:xfrm>
           <a:prstGeom prst="roundRect">
             <a:avLst/>
           </a:prstGeom>
           <a:solidFill>
-            <a:srgbClr val="E6F7EE"/>
+            <a:srgbClr val="EEF7F1"/>
           </a:solidFill>
           <a:ln>
             <a:solidFill>
-              <a:srgbClr val="2E7D5A"/>
+              <a:srgbClr val="CDDAE8"/>
             </a:solidFill>
           </a:ln>
         </p:spPr>
@@ -5267,14 +4872,162 @@
       </p:sp>
       <p:sp>
         <p:nvSpPr>
+          <p:cNvPr id="8" name="TextBox 7"/>
+          <p:cNvSpPr txBox="1"/>
+          <p:nvPr/>
+        </p:nvSpPr>
+        <p:spPr>
+          <a:xfrm>
+            <a:off x="704088" y="2880360"/>
+            <a:ext cx="3438144" cy="292608"/>
+          </a:xfrm>
+          <a:prstGeom prst="rect">
+            <a:avLst/>
+          </a:prstGeom>
+          <a:noFill/>
+        </p:spPr>
+        <p:txBody>
+          <a:bodyPr wrap="none">
+            <a:spAutoFit/>
+          </a:bodyPr>
+          <a:lstStyle/>
+          <a:p>
+            <a:pPr>
+              <a:defRPr sz="1350" b="1">
+                <a:solidFill>
+                  <a:srgbClr val="2E7D5A"/>
+                </a:solidFill>
+              </a:defRPr>
+            </a:pPr>
+            <a:r>
+              <a:t>Why the result is meaningful</a:t>
+            </a:r>
+          </a:p>
+        </p:txBody>
+      </p:sp>
+      <p:sp>
+        <p:nvSpPr>
           <p:cNvPr id="9" name="TextBox 8"/>
           <p:cNvSpPr txBox="1"/>
           <p:nvPr/>
         </p:nvSpPr>
         <p:spPr>
           <a:xfrm>
-            <a:off x="6903720" y="3611880"/>
-            <a:ext cx="3840480" cy="1508760"/>
+            <a:off x="704088" y="3264408"/>
+            <a:ext cx="3438144" cy="822960"/>
+          </a:xfrm>
+          <a:prstGeom prst="rect">
+            <a:avLst/>
+          </a:prstGeom>
+          <a:noFill/>
+        </p:spPr>
+        <p:txBody>
+          <a:bodyPr wrap="square">
+            <a:spAutoFit/>
+          </a:bodyPr>
+          <a:lstStyle/>
+          <a:p>
+            <a:pPr>
+              <a:spcAft>
+                <a:spcPts val="400"/>
+              </a:spcAft>
+              <a:defRPr sz="1250">
+                <a:solidFill>
+                  <a:srgbClr val="1C222D"/>
+                </a:solidFill>
+              </a:defRPr>
+            </a:pPr>
+            <a:r>
+              <a:t>Partial-mask reconstruction follows target-like spectral blocks</a:t>
+            </a:r>
+          </a:p>
+          <a:p>
+            <a:pPr>
+              <a:spcAft>
+                <a:spcPts val="400"/>
+              </a:spcAft>
+              <a:defRPr sz="1250">
+                <a:solidFill>
+                  <a:srgbClr val="1C222D"/>
+                </a:solidFill>
+              </a:defRPr>
+            </a:pPr>
+            <a:r>
+              <a:t>Output is not only unstructured noise</a:t>
+            </a:r>
+          </a:p>
+          <a:p>
+            <a:pPr>
+              <a:spcAft>
+                <a:spcPts val="400"/>
+              </a:spcAft>
+              <a:defRPr sz="1250">
+                <a:solidFill>
+                  <a:srgbClr val="1C222D"/>
+                </a:solidFill>
+              </a:defRPr>
+            </a:pPr>
+            <a:r>
+              <a:t>Full 100% mask remains the bottleneck</a:t>
+            </a:r>
+          </a:p>
+        </p:txBody>
+      </p:sp>
+      <p:sp>
+        <p:nvSpPr>
+          <p:cNvPr id="10" name="Rounded Rectangle 9"/>
+          <p:cNvSpPr/>
+          <p:nvPr/>
+        </p:nvSpPr>
+        <p:spPr>
+          <a:xfrm>
+            <a:off x="502920" y="4370832"/>
+            <a:ext cx="3840480" cy="1143000"/>
+          </a:xfrm>
+          <a:prstGeom prst="roundRect">
+            <a:avLst/>
+          </a:prstGeom>
+          <a:solidFill>
+            <a:srgbClr val="FFFFFF"/>
+          </a:solidFill>
+          <a:ln>
+            <a:solidFill>
+              <a:srgbClr val="CDDAE8"/>
+            </a:solidFill>
+          </a:ln>
+        </p:spPr>
+        <p:style>
+          <a:lnRef idx="1">
+            <a:schemeClr val="accent1"/>
+          </a:lnRef>
+          <a:fillRef idx="3">
+            <a:schemeClr val="accent1"/>
+          </a:fillRef>
+          <a:effectRef idx="2">
+            <a:schemeClr val="accent1"/>
+          </a:effectRef>
+          <a:fontRef idx="minor">
+            <a:schemeClr val="lt1"/>
+          </a:fontRef>
+        </p:style>
+        <p:txBody>
+          <a:bodyPr rtlCol="0" anchor="ctr"/>
+          <a:lstStyle/>
+          <a:p>
+            <a:pPr algn="ctr"/>
+          </a:p>
+        </p:txBody>
+      </p:sp>
+      <p:sp>
+        <p:nvSpPr>
+          <p:cNvPr id="11" name="TextBox 10"/>
+          <p:cNvSpPr txBox="1"/>
+          <p:nvPr/>
+        </p:nvSpPr>
+        <p:spPr>
+          <a:xfrm>
+            <a:off x="704088" y="4507992"/>
+            <a:ext cx="3438144" cy="292608"/>
           </a:xfrm>
           <a:prstGeom prst="rect">
             <a:avLst/>
@@ -5287,22 +5040,127 @@
           </a:bodyPr>
           <a:lstStyle/>
           <a:p>
-            <a:pPr algn="ctr">
-              <a:defRPr sz="2800" b="1">
-                <a:solidFill>
-                  <a:srgbClr val="2E7D5A"/>
+            <a:pPr>
+              <a:defRPr sz="1350" b="1">
+                <a:solidFill>
+                  <a:srgbClr val="2969B0"/>
                 </a:solidFill>
               </a:defRPr>
             </a:pPr>
             <a:r>
-              <a:t>Validation loss improved by ~12.3%</a:t>
-            </a:r>
-          </a:p>
-        </p:txBody>
-      </p:sp>
-      <p:sp>
-        <p:nvSpPr>
-          <p:cNvPr id="10" name="Rectangle 9"/>
+              <a:t>Evidence shown at right</a:t>
+            </a:r>
+          </a:p>
+        </p:txBody>
+      </p:sp>
+      <p:sp>
+        <p:nvSpPr>
+          <p:cNvPr id="12" name="TextBox 11"/>
+          <p:cNvSpPr txBox="1"/>
+          <p:nvPr/>
+        </p:nvSpPr>
+        <p:spPr>
+          <a:xfrm>
+            <a:off x="704088" y="4892040"/>
+            <a:ext cx="3438144" cy="548640"/>
+          </a:xfrm>
+          <a:prstGeom prst="rect">
+            <a:avLst/>
+          </a:prstGeom>
+          <a:noFill/>
+        </p:spPr>
+        <p:txBody>
+          <a:bodyPr wrap="square">
+            <a:spAutoFit/>
+          </a:bodyPr>
+          <a:lstStyle/>
+          <a:p>
+            <a:pPr>
+              <a:spcAft>
+                <a:spcPts val="400"/>
+              </a:spcAft>
+              <a:defRPr sz="1200">
+                <a:solidFill>
+                  <a:srgbClr val="1C222D"/>
+                </a:solidFill>
+              </a:defRPr>
+            </a:pPr>
+            <a:r>
+              <a:t>Full diagnostic mel-spectrogram: context, target, codec reconstruction, partial reconstructions, and full generation.</a:t>
+            </a:r>
+          </a:p>
+        </p:txBody>
+      </p:sp>
+      <p:pic>
+        <p:nvPicPr>
+          <p:cNvPr id="13" name="Picture 12" descr="diagnostic_mels.png"/>
+          <p:cNvPicPr>
+            <a:picLocks noChangeAspect="1"/>
+          </p:cNvPicPr>
+          <p:nvPr/>
+        </p:nvPicPr>
+        <p:blipFill>
+          <a:blip r:embed="rId2"/>
+          <a:stretch>
+            <a:fillRect/>
+          </a:stretch>
+        </p:blipFill>
+        <p:spPr>
+          <a:xfrm>
+            <a:off x="4617720" y="1143000"/>
+            <a:ext cx="3801291" cy="5321808"/>
+          </a:xfrm>
+          <a:prstGeom prst="rect">
+            <a:avLst/>
+          </a:prstGeom>
+        </p:spPr>
+      </p:pic>
+      <p:sp>
+        <p:nvSpPr>
+          <p:cNvPr id="14" name="Rectangle 13"/>
+          <p:cNvSpPr/>
+          <p:nvPr/>
+        </p:nvSpPr>
+        <p:spPr>
+          <a:xfrm>
+            <a:off x="4617720" y="1143000"/>
+            <a:ext cx="3801291" cy="5321808"/>
+          </a:xfrm>
+          <a:prstGeom prst="rect">
+            <a:avLst/>
+          </a:prstGeom>
+          <a:noFill/>
+          <a:ln w="10160">
+            <a:solidFill>
+              <a:srgbClr val="BEC8D4"/>
+            </a:solidFill>
+          </a:ln>
+        </p:spPr>
+        <p:style>
+          <a:lnRef idx="1">
+            <a:schemeClr val="accent1"/>
+          </a:lnRef>
+          <a:fillRef idx="3">
+            <a:schemeClr val="accent1"/>
+          </a:fillRef>
+          <a:effectRef idx="2">
+            <a:schemeClr val="accent1"/>
+          </a:effectRef>
+          <a:fontRef idx="minor">
+            <a:schemeClr val="lt1"/>
+          </a:fontRef>
+        </p:style>
+        <p:txBody>
+          <a:bodyPr rtlCol="0" anchor="ctr"/>
+          <a:lstStyle/>
+          <a:p>
+            <a:pPr algn="ctr"/>
+          </a:p>
+        </p:txBody>
+      </p:sp>
+      <p:sp>
+        <p:nvSpPr>
+          <p:cNvPr id="15" name="Rectangle 14"/>
           <p:cNvSpPr/>
           <p:nvPr/>
         </p:nvSpPr>
@@ -5347,7 +5205,7 @@
       </p:sp>
       <p:sp>
         <p:nvSpPr>
-          <p:cNvPr id="11" name="TextBox 10"/>
+          <p:cNvPr id="16" name="TextBox 15"/>
           <p:cNvSpPr txBox="1"/>
           <p:nvPr/>
         </p:nvSpPr>
@@ -5382,7 +5240,7 @@
       </p:sp>
       <p:sp>
         <p:nvSpPr>
-          <p:cNvPr id="12" name="TextBox 11"/>
+          <p:cNvPr id="17" name="TextBox 16"/>
           <p:cNvSpPr txBox="1"/>
           <p:nvPr/>
         </p:nvSpPr>
@@ -5441,8 +5299,8 @@
         </p:nvSpPr>
         <p:spPr>
           <a:xfrm>
-            <a:off x="502920" y="320040"/>
-            <a:ext cx="11155680" cy="685800"/>
+            <a:off x="502920" y="292608"/>
+            <a:ext cx="11155680" cy="566928"/>
           </a:xfrm>
           <a:prstGeom prst="rect">
             <a:avLst/>
@@ -5456,7 +5314,7 @@
           <a:lstStyle/>
           <a:p>
             <a:pPr>
-              <a:defRPr sz="3000" b="1">
+              <a:defRPr sz="2800" b="1">
                 <a:solidFill>
                   <a:srgbClr val="142D50"/>
                 </a:solidFill>
@@ -5521,8 +5379,8 @@
         </p:nvSpPr>
         <p:spPr>
           <a:xfrm>
-            <a:off x="914400" y="1490472"/>
-            <a:ext cx="4892040" cy="320040"/>
+            <a:off x="886968" y="1463039"/>
+            <a:ext cx="4946903" cy="292608"/>
           </a:xfrm>
           <a:prstGeom prst="rect">
             <a:avLst/>
@@ -5536,7 +5394,7 @@
           <a:lstStyle/>
           <a:p>
             <a:pPr>
-              <a:defRPr sz="1400" b="1">
+              <a:defRPr sz="1350" b="1">
                 <a:solidFill>
                   <a:srgbClr val="2969B0"/>
                 </a:solidFill>
@@ -5556,8 +5414,8 @@
         </p:nvSpPr>
         <p:spPr>
           <a:xfrm>
-            <a:off x="914400" y="1920240"/>
-            <a:ext cx="4892040" cy="3767328"/>
+            <a:off x="886968" y="1847088"/>
+            <a:ext cx="4946903" cy="3886200"/>
           </a:xfrm>
           <a:prstGeom prst="rect">
             <a:avLst/>
@@ -5565,7 +5423,7 @@
           <a:noFill/>
         </p:spPr>
         <p:txBody>
-          <a:bodyPr wrap="none">
+          <a:bodyPr wrap="square">
             <a:spAutoFit/>
           </a:bodyPr>
           <a:lstStyle/>
@@ -5574,7 +5432,7 @@
               <a:spcAft>
                 <a:spcPts val="400"/>
               </a:spcAft>
-              <a:defRPr sz="1500">
+              <a:defRPr sz="1400">
                 <a:solidFill>
                   <a:srgbClr val="1C222D"/>
                 </a:solidFill>
@@ -5589,14 +5447,14 @@
               <a:spcAft>
                 <a:spcPts val="400"/>
               </a:spcAft>
-              <a:defRPr sz="1500">
+              <a:defRPr sz="1400">
                 <a:solidFill>
                   <a:srgbClr val="1C222D"/>
                 </a:solidFill>
               </a:defRPr>
             </a:pPr>
             <a:r>
-              <a:t>Partial-mask reconstruction shows audible structure</a:t>
+              <a:t>Partial-mask reconstruction shows audible and spectral structure</a:t>
             </a:r>
           </a:p>
           <a:p>
@@ -5604,14 +5462,14 @@
               <a:spcAft>
                 <a:spcPts val="400"/>
               </a:spcAft>
-              <a:defRPr sz="1500">
+              <a:defRPr sz="1400">
                 <a:solidFill>
                   <a:srgbClr val="1C222D"/>
                 </a:solidFill>
               </a:defRPr>
             </a:pPr>
             <a:r>
-              <a:t>Larger track coverage + less overlap improved metrics</a:t>
+              <a:t>Larger track coverage + less overlap improved validation metrics</a:t>
             </a:r>
           </a:p>
         </p:txBody>
@@ -5669,8 +5527,8 @@
         </p:nvSpPr>
         <p:spPr>
           <a:xfrm>
-            <a:off x="6537960" y="1490472"/>
-            <a:ext cx="4800600" cy="320040"/>
+            <a:off x="6510528" y="1463039"/>
+            <a:ext cx="4855464" cy="292608"/>
           </a:xfrm>
           <a:prstGeom prst="rect">
             <a:avLst/>
@@ -5684,7 +5542,7 @@
           <a:lstStyle/>
           <a:p>
             <a:pPr>
-              <a:defRPr sz="1400" b="1">
+              <a:defRPr sz="1350" b="1">
                 <a:solidFill>
                   <a:srgbClr val="2969B0"/>
                 </a:solidFill>
@@ -5704,8 +5562,8 @@
         </p:nvSpPr>
         <p:spPr>
           <a:xfrm>
-            <a:off x="6537960" y="1920240"/>
-            <a:ext cx="4800600" cy="1344168"/>
+            <a:off x="6510528" y="1847088"/>
+            <a:ext cx="4855464" cy="1463040"/>
           </a:xfrm>
           <a:prstGeom prst="rect">
             <a:avLst/>
@@ -5713,7 +5571,7 @@
           <a:noFill/>
         </p:spPr>
         <p:txBody>
-          <a:bodyPr wrap="none">
+          <a:bodyPr wrap="square">
             <a:spAutoFit/>
           </a:bodyPr>
           <a:lstStyle/>
@@ -5722,7 +5580,7 @@
               <a:spcAft>
                 <a:spcPts val="400"/>
               </a:spcAft>
-              <a:defRPr sz="1500">
+              <a:defRPr sz="1400">
                 <a:solidFill>
                   <a:srgbClr val="1C222D"/>
                 </a:solidFill>
@@ -5737,7 +5595,7 @@
               <a:spcAft>
                 <a:spcPts val="400"/>
               </a:spcAft>
-              <a:defRPr sz="1500">
+              <a:defRPr sz="1400">
                 <a:solidFill>
                   <a:srgbClr val="1C222D"/>
                 </a:solidFill>
@@ -5802,8 +5660,8 @@
         </p:nvSpPr>
         <p:spPr>
           <a:xfrm>
-            <a:off x="6537960" y="3867911"/>
-            <a:ext cx="4800600" cy="320040"/>
+            <a:off x="6510528" y="3840480"/>
+            <a:ext cx="4855464" cy="292608"/>
           </a:xfrm>
           <a:prstGeom prst="rect">
             <a:avLst/>
@@ -5817,9 +5675,9 @@
           <a:lstStyle/>
           <a:p>
             <a:pPr>
-              <a:defRPr sz="1400" b="1">
-                <a:solidFill>
-                  <a:srgbClr val="2969B0"/>
+              <a:defRPr sz="1350" b="1">
+                <a:solidFill>
+                  <a:srgbClr val="2E7D5A"/>
                 </a:solidFill>
               </a:defRPr>
             </a:pPr>
@@ -5837,8 +5695,8 @@
         </p:nvSpPr>
         <p:spPr>
           <a:xfrm>
-            <a:off x="6537960" y="4297680"/>
-            <a:ext cx="4800600" cy="1389887"/>
+            <a:off x="6510528" y="4224528"/>
+            <a:ext cx="4855464" cy="1508760"/>
           </a:xfrm>
           <a:prstGeom prst="rect">
             <a:avLst/>
@@ -5846,7 +5704,7 @@
           <a:noFill/>
         </p:spPr>
         <p:txBody>
-          <a:bodyPr wrap="none">
+          <a:bodyPr wrap="square">
             <a:spAutoFit/>
           </a:bodyPr>
           <a:lstStyle/>
@@ -5855,7 +5713,7 @@
               <a:spcAft>
                 <a:spcPts val="400"/>
               </a:spcAft>
-              <a:defRPr sz="1500">
+              <a:defRPr sz="1400">
                 <a:solidFill>
                   <a:srgbClr val="1C222D"/>
                 </a:solidFill>
@@ -5870,7 +5728,7 @@
               <a:spcAft>
                 <a:spcPts val="400"/>
               </a:spcAft>
-              <a:defRPr sz="1500">
+              <a:defRPr sz="1400">
                 <a:solidFill>
                   <a:srgbClr val="1C222D"/>
                 </a:solidFill>
@@ -5885,7 +5743,7 @@
               <a:spcAft>
                 <a:spcPts val="400"/>
               </a:spcAft>
-              <a:defRPr sz="1500">
+              <a:defRPr sz="1400">
                 <a:solidFill>
                   <a:srgbClr val="1C222D"/>
                 </a:solidFill>

</xml_diff>